<commit_message>
update settings on slide deck
</commit_message>
<xml_diff>
--- a/topic08-inheritance/unit-08a-lectures/talk-3-inheritance-v2/a-inheritance-v2.pptx
+++ b/topic08-inheritance/unit-08a-lectures/talk-3-inheritance-v2/a-inheritance-v2.pptx
@@ -270,7 +270,7 @@
           <a:p>
             <a:fld id="{73FB268A-CA3A-0048-9013-6E7C8FF5127F}" type="datetimeFigureOut">
               <a:rPr lang="en-US" smtClean="0"/>
-              <a:t>3/13/26</a:t>
+              <a:t>3/18/26</a:t>
             </a:fld>
             <a:endParaRPr lang="en-US"/>
           </a:p>
@@ -2486,7 +2486,7 @@
             <a:fld id="{1D8BD707-D9CF-40AE-B4C6-C98DA3205C09}" type="datetimeFigureOut">
               <a:rPr lang="en-US" smtClean="0"/>
               <a:pPr/>
-              <a:t>3/13/26</a:t>
+              <a:t>3/18/26</a:t>
             </a:fld>
             <a:endParaRPr lang="en-US"/>
           </a:p>
@@ -2721,7 +2721,7 @@
             <a:fld id="{1D8BD707-D9CF-40AE-B4C6-C98DA3205C09}" type="datetimeFigureOut">
               <a:rPr lang="en-US" smtClean="0"/>
               <a:pPr/>
-              <a:t>3/13/26</a:t>
+              <a:t>3/18/26</a:t>
             </a:fld>
             <a:endParaRPr lang="en-US"/>
           </a:p>
@@ -3251,7 +3251,7 @@
             <a:fld id="{1D8BD707-D9CF-40AE-B4C6-C98DA3205C09}" type="datetimeFigureOut">
               <a:rPr lang="en-US" smtClean="0"/>
               <a:pPr/>
-              <a:t>3/13/26</a:t>
+              <a:t>3/18/26</a:t>
             </a:fld>
             <a:endParaRPr lang="en-US"/>
           </a:p>
@@ -3780,7 +3780,7 @@
           </a:ln>
           <a:extLst>
             <a:ext uri="{C572A759-6A51-4108-AA02-DFA0A04FC94B}">
-              <ma14:wrappingTextBoxFlag xmlns="" xmlns:ma14="http://schemas.microsoft.com/office/mac/drawingml/2011/main" val="1"/>
+              <ma14:wrappingTextBoxFlag xmlns:ma14="http://schemas.microsoft.com/office/mac/drawingml/2011/main" xmlns="" val="1"/>
             </a:ext>
           </a:extLst>
         </p:spPr>
@@ -3867,7 +3867,7 @@
             <a:effectLst/>
             <a:extLst>
               <a:ext uri="{C572A759-6A51-4108-AA02-DFA0A04FC94B}">
-                <ma14:wrappingTextBoxFlag xmlns="" xmlns:ma14="http://schemas.microsoft.com/office/mac/drawingml/2011/main" val="1"/>
+                <ma14:wrappingTextBoxFlag xmlns:ma14="http://schemas.microsoft.com/office/mac/drawingml/2011/main" xmlns="" val="1"/>
               </a:ext>
             </a:extLst>
           </p:spPr>
@@ -3940,7 +3940,7 @@
             <a:effectLst/>
             <a:extLst>
               <a:ext uri="{C572A759-6A51-4108-AA02-DFA0A04FC94B}">
-                <ma14:wrappingTextBoxFlag xmlns="" xmlns:ma14="http://schemas.microsoft.com/office/mac/drawingml/2011/main" val="1"/>
+                <ma14:wrappingTextBoxFlag xmlns:ma14="http://schemas.microsoft.com/office/mac/drawingml/2011/main" xmlns="" val="1"/>
               </a:ext>
             </a:extLst>
           </p:spPr>
@@ -3991,7 +3991,7 @@
             <a:effectLst/>
             <a:extLst>
               <a:ext uri="{C572A759-6A51-4108-AA02-DFA0A04FC94B}">
-                <ma14:wrappingTextBoxFlag xmlns="" xmlns:ma14="http://schemas.microsoft.com/office/mac/drawingml/2011/main" val="1"/>
+                <ma14:wrappingTextBoxFlag xmlns:ma14="http://schemas.microsoft.com/office/mac/drawingml/2011/main" xmlns="" val="1"/>
               </a:ext>
             </a:extLst>
           </p:spPr>
@@ -5644,7 +5644,7 @@
             <a:fld id="{1D8BD707-D9CF-40AE-B4C6-C98DA3205C09}" type="datetimeFigureOut">
               <a:rPr lang="en-US" smtClean="0"/>
               <a:pPr/>
-              <a:t>3/13/26</a:t>
+              <a:t>3/18/26</a:t>
             </a:fld>
             <a:endParaRPr lang="en-US"/>
           </a:p>
@@ -6278,7 +6278,7 @@
             <a:fld id="{1D8BD707-D9CF-40AE-B4C6-C98DA3205C09}" type="datetimeFigureOut">
               <a:rPr lang="en-US" smtClean="0"/>
               <a:pPr/>
-              <a:t>3/13/26</a:t>
+              <a:t>3/18/26</a:t>
             </a:fld>
             <a:endParaRPr lang="en-US"/>
           </a:p>
@@ -6927,7 +6927,7 @@
             <a:fld id="{1D8BD707-D9CF-40AE-B4C6-C98DA3205C09}" type="datetimeFigureOut">
               <a:rPr lang="en-US" smtClean="0"/>
               <a:pPr/>
-              <a:t>3/13/26</a:t>
+              <a:t>3/18/26</a:t>
             </a:fld>
             <a:endParaRPr lang="en-US"/>
           </a:p>
@@ -7741,7 +7741,7 @@
             <a:fld id="{1D8BD707-D9CF-40AE-B4C6-C98DA3205C09}" type="datetimeFigureOut">
               <a:rPr lang="en-US" smtClean="0"/>
               <a:pPr/>
-              <a:t>3/13/26</a:t>
+              <a:t>3/18/26</a:t>
             </a:fld>
             <a:endParaRPr lang="en-US"/>
           </a:p>
@@ -8255,7 +8255,7 @@
             <a:fld id="{1D8BD707-D9CF-40AE-B4C6-C98DA3205C09}" type="datetimeFigureOut">
               <a:rPr lang="en-US" smtClean="0"/>
               <a:pPr/>
-              <a:t>3/13/26</a:t>
+              <a:t>3/18/26</a:t>
             </a:fld>
             <a:endParaRPr lang="en-US"/>
           </a:p>
@@ -8735,7 +8735,7 @@
             <a:fld id="{1D8BD707-D9CF-40AE-B4C6-C98DA3205C09}" type="datetimeFigureOut">
               <a:rPr lang="en-US" smtClean="0"/>
               <a:pPr/>
-              <a:t>3/13/26</a:t>
+              <a:t>3/18/26</a:t>
             </a:fld>
             <a:endParaRPr lang="en-US"/>
           </a:p>
@@ -9015,7 +9015,7 @@
             <a:fld id="{1D8BD707-D9CF-40AE-B4C6-C98DA3205C09}" type="datetimeFigureOut">
               <a:rPr lang="en-US" smtClean="0"/>
               <a:pPr/>
-              <a:t>3/13/26</a:t>
+              <a:t>3/18/26</a:t>
             </a:fld>
             <a:endParaRPr lang="en-US"/>
           </a:p>
@@ -9622,7 +9622,7 @@
             <a:fld id="{1D8BD707-D9CF-40AE-B4C6-C98DA3205C09}" type="datetimeFigureOut">
               <a:rPr lang="en-US" smtClean="0"/>
               <a:pPr/>
-              <a:t>3/13/26</a:t>
+              <a:t>3/18/26</a:t>
             </a:fld>
             <a:endParaRPr lang="en-US"/>
           </a:p>
@@ -10185,7 +10185,7 @@
             <a:fld id="{1D8BD707-D9CF-40AE-B4C6-C98DA3205C09}" type="datetimeFigureOut">
               <a:rPr lang="en-US" smtClean="0"/>
               <a:pPr/>
-              <a:t>3/13/26</a:t>
+              <a:t>3/18/26</a:t>
             </a:fld>
             <a:endParaRPr lang="en-US"/>
           </a:p>
@@ -27348,6 +27348,23 @@
 </file>
 
 <file path=customXml/item1.xml><?xml version="1.0" encoding="utf-8"?>
+<?mso-contentType ?>
+<FormTemplates xmlns="http://schemas.microsoft.com/sharepoint/v3/contenttype/forms">
+  <Display>DocumentLibraryForm</Display>
+  <Edit>DocumentLibraryForm</Edit>
+  <New>DocumentLibraryForm</New>
+</FormTemplates>
+</file>
+
+<file path=customXml/item2.xml><?xml version="1.0" encoding="utf-8"?>
+<p:properties xmlns:p="http://schemas.microsoft.com/office/2006/metadata/properties" xmlns:xsi="http://www.w3.org/2001/XMLSchema-instance" xmlns:pc="http://schemas.microsoft.com/office/infopath/2007/PartnerControls">
+  <documentManagement>
+    <_activity xmlns="2e073d95-02bc-4c31-9707-1f7b5f2564cb" xsi:nil="true"/>
+  </documentManagement>
+</p:properties>
+</file>
+
+<file path=customXml/item3.xml><?xml version="1.0" encoding="utf-8"?>
 <ct:contentTypeSchema xmlns:ct="http://schemas.microsoft.com/office/2006/metadata/contentType" xmlns:ma="http://schemas.microsoft.com/office/2006/metadata/properties/metaAttributes" ct:_="" ma:_="" ma:contentTypeName="Document" ma:contentTypeID="0x01010074A7B4F4F87092419B4836663A979F72" ma:contentTypeVersion="12" ma:contentTypeDescription="Create a new document." ma:contentTypeScope="" ma:versionID="1705185788f4f7b8606867508f74a2eb">
   <xsd:schema xmlns:xsd="http://www.w3.org/2001/XMLSchema" xmlns:xs="http://www.w3.org/2001/XMLSchema" xmlns:p="http://schemas.microsoft.com/office/2006/metadata/properties" xmlns:ns3="2e073d95-02bc-4c31-9707-1f7b5f2564cb" xmlns:ns4="ecd595b7-854d-4129-8908-394d58e21de0" targetNamespace="http://schemas.microsoft.com/office/2006/metadata/properties" ma:root="true" ma:fieldsID="784458e58d0eaf4d4fb689770e9f109b" ns3:_="" ns4:_="">
     <xsd:import namespace="2e073d95-02bc-4c31-9707-1f7b5f2564cb"/>
@@ -27562,38 +27579,10 @@
 </ct:contentTypeSchema>
 </file>
 
-<file path=customXml/item2.xml><?xml version="1.0" encoding="utf-8"?>
-<p:properties xmlns:p="http://schemas.microsoft.com/office/2006/metadata/properties" xmlns:xsi="http://www.w3.org/2001/XMLSchema-instance" xmlns:pc="http://schemas.microsoft.com/office/infopath/2007/PartnerControls">
-  <documentManagement>
-    <_activity xmlns="2e073d95-02bc-4c31-9707-1f7b5f2564cb" xsi:nil="true"/>
-  </documentManagement>
-</p:properties>
-</file>
-
-<file path=customXml/item3.xml><?xml version="1.0" encoding="utf-8"?>
-<?mso-contentType ?>
-<FormTemplates xmlns="http://schemas.microsoft.com/sharepoint/v3/contenttype/forms">
-  <Display>DocumentLibraryForm</Display>
-  <Edit>DocumentLibraryForm</Edit>
-  <New>DocumentLibraryForm</New>
-</FormTemplates>
-</file>
-
 <file path=customXml/itemProps1.xml><?xml version="1.0" encoding="utf-8"?>
-<ds:datastoreItem xmlns:ds="http://schemas.openxmlformats.org/officeDocument/2006/customXml" ds:itemID="{5A847694-5366-4F35-BB14-1B44805440D6}">
+<ds:datastoreItem xmlns:ds="http://schemas.openxmlformats.org/officeDocument/2006/customXml" ds:itemID="{9F0734DE-2FC5-4E40-8FD1-4F58D8D2451F}">
   <ds:schemaRefs>
-    <ds:schemaRef ds:uri="http://schemas.microsoft.com/office/2006/metadata/contentType"/>
-    <ds:schemaRef ds:uri="http://schemas.microsoft.com/office/2006/metadata/properties/metaAttributes"/>
-    <ds:schemaRef ds:uri="http://www.w3.org/2001/XMLSchema"/>
-    <ds:schemaRef ds:uri="http://schemas.microsoft.com/office/2006/metadata/properties"/>
-    <ds:schemaRef ds:uri="2e073d95-02bc-4c31-9707-1f7b5f2564cb"/>
-    <ds:schemaRef ds:uri="ecd595b7-854d-4129-8908-394d58e21de0"/>
-    <ds:schemaRef ds:uri="http://schemas.microsoft.com/office/2006/documentManagement/types"/>
-    <ds:schemaRef ds:uri="http://schemas.microsoft.com/office/infopath/2007/PartnerControls"/>
-    <ds:schemaRef ds:uri="http://schemas.openxmlformats.org/package/2006/metadata/core-properties"/>
-    <ds:schemaRef ds:uri="http://purl.org/dc/elements/1.1/"/>
-    <ds:schemaRef ds:uri="http://purl.org/dc/terms/"/>
-    <ds:schemaRef ds:uri="http://schemas.microsoft.com/internal/obd"/>
+    <ds:schemaRef ds:uri="http://schemas.microsoft.com/sharepoint/v3/contenttype/forms"/>
   </ds:schemaRefs>
 </ds:datastoreItem>
 </file>
@@ -27616,9 +27605,20 @@
 </file>
 
 <file path=customXml/itemProps3.xml><?xml version="1.0" encoding="utf-8"?>
-<ds:datastoreItem xmlns:ds="http://schemas.openxmlformats.org/officeDocument/2006/customXml" ds:itemID="{9F0734DE-2FC5-4E40-8FD1-4F58D8D2451F}">
+<ds:datastoreItem xmlns:ds="http://schemas.openxmlformats.org/officeDocument/2006/customXml" ds:itemID="{5A847694-5366-4F35-BB14-1B44805440D6}">
   <ds:schemaRefs>
-    <ds:schemaRef ds:uri="http://schemas.microsoft.com/sharepoint/v3/contenttype/forms"/>
+    <ds:schemaRef ds:uri="http://schemas.microsoft.com/office/2006/metadata/contentType"/>
+    <ds:schemaRef ds:uri="http://schemas.microsoft.com/office/2006/metadata/properties/metaAttributes"/>
+    <ds:schemaRef ds:uri="http://www.w3.org/2001/XMLSchema"/>
+    <ds:schemaRef ds:uri="http://schemas.microsoft.com/office/2006/metadata/properties"/>
+    <ds:schemaRef ds:uri="2e073d95-02bc-4c31-9707-1f7b5f2564cb"/>
+    <ds:schemaRef ds:uri="ecd595b7-854d-4129-8908-394d58e21de0"/>
+    <ds:schemaRef ds:uri="http://schemas.microsoft.com/office/2006/documentManagement/types"/>
+    <ds:schemaRef ds:uri="http://schemas.microsoft.com/office/infopath/2007/PartnerControls"/>
+    <ds:schemaRef ds:uri="http://schemas.openxmlformats.org/package/2006/metadata/core-properties"/>
+    <ds:schemaRef ds:uri="http://purl.org/dc/elements/1.1/"/>
+    <ds:schemaRef ds:uri="http://purl.org/dc/terms/"/>
+    <ds:schemaRef ds:uri="http://schemas.microsoft.com/internal/obd"/>
   </ds:schemaRefs>
 </ds:datastoreItem>
 </file>
</xml_diff>